<commit_message>
Slides: week 12 in progress
Co-Authored-By: Claude Opus 5.5 <noreply@anthropic.com>
Claude-Session: https://claude.ai/code/session_01XkzKv8pUGMF9AsqSCMpnBq
</commit_message>
<xml_diff>
--- a/slides/decks/s12-survivorship-late-effects.pptx
+++ b/slides/decks/s12-survivorship-late-effects.pptx
@@ -134,19 +134,19 @@
   <p:extLst>
     <p:ext uri="{521415D9-36F7-43E2-AB2F-B90AF26B5E84}">
       <p14:sectionLst xmlns:p14="http://schemas.microsoft.com/office/powerpoint/2010/main">
-        <p14:section name="Opening" id="{5a5e91a4-c4ed-16bb-859f-9a856568aade}">
+        <p14:section name="Opening" id="{085400a7-5ce9-98c3-c5c2-6baba6b921df}">
           <p14:sldIdLst>
             <p14:sldId id="256"/>
             <p14:sldId id="257"/>
           </p14:sldIdLst>
         </p14:section>
-        <p14:section name="Follow-up framework" id="{2892e587-e971-03b2-debf-bab357dda85d}">
+        <p14:section name="Follow-up framework" id="{48636475-5a57-da19-ddf3-37db3cee2322}">
           <p14:sldIdLst>
             <p14:sldId id="258"/>
             <p14:sldId id="259"/>
           </p14:sldIdLst>
         </p14:section>
-        <p14:section name="Vaccination" id="{e58667ba-f7b7-1349-27a4-b1e4766e5f6d}">
+        <p14:section name="Vaccination" id="{ed611389-9082-b0ee-8a93-b0890ef40fcb}">
           <p14:sldIdLst>
             <p14:sldId id="260"/>
             <p14:sldId id="261"/>
@@ -154,14 +154,14 @@
             <p14:sldId id="263"/>
           </p14:sldIdLst>
         </p14:section>
-        <p14:section name="Iron overload" id="{de3f20f9-21ed-73ed-4710-58b1b8528a20}">
+        <p14:section name="Iron overload" id="{86e90c05-b90f-8f8f-222f-1124582d0e56}">
           <p14:sldIdLst>
             <p14:sldId id="264"/>
             <p14:sldId id="265"/>
             <p14:sldId id="266"/>
           </p14:sldIdLst>
         </p14:section>
-        <p14:section name="Secondary neoplasia" id="{606f9da7-dcbb-e2e5-9605-17856c667d25}">
+        <p14:section name="Secondary neoplasia" id="{ebedae57-707c-6fb7-3529-7265a46202e1}">
           <p14:sldIdLst>
             <p14:sldId id="267"/>
             <p14:sldId id="268"/>
@@ -169,12 +169,12 @@
             <p14:sldId id="270"/>
           </p14:sldIdLst>
         </p14:section>
-        <p14:section name="Cardiometabolic and endocrine" id="{d55a27fd-cba3-38ea-8c4f-3e6d206a7317}">
+        <p14:section name="Cardiometabolic and endocrine" id="{652ca33d-ab71-d9c6-f19d-6bf969e187eb}">
           <p14:sldIdLst>
             <p14:sldId id="271"/>
           </p14:sldIdLst>
         </p14:section>
-        <p14:section name="Board questions" id="{27ec114f-cd9b-4e90-0495-6ab36ff59991}">
+        <p14:section name="Board questions" id="{83035cf1-1154-07ae-165d-00d79590101e}">
           <p14:sldIdLst>
             <p14:sldId id="272"/>
             <p14:sldId id="273"/>
@@ -184,13 +184,13 @@
             <p14:sldId id="277"/>
           </p14:sldIdLst>
         </p14:section>
-        <p14:section name="References" id="{e821324c-79d7-3d62-35a9-7f91822ef3ef}">
+        <p14:section name="References" id="{a2834c61-bddf-5f78-0d1a-08d7e4157989}">
           <p14:sldIdLst>
             <p14:sldId id="278"/>
             <p14:sldId id="279"/>
           </p14:sldIdLst>
         </p14:section>
-        <p14:section name="Backup" id="{2d0ef952-a4ee-4d78-34c9-e656959b67e2}">
+        <p14:section name="Backup" id="{7f870b8c-6cad-a79a-66a5-f4eaa7a337ca}">
           <p14:sldIdLst>
             <p14:sldId id="280"/>
             <p14:sldId id="281"/>
@@ -23332,7 +23332,7 @@
                   <a:schemeClr val="tx1"/>
                 </a:solidFill>
               </a:rPr>
-              <a:t>Give on schedule; controlled GVHD no delay</a:t>
+              <a:t>On schedule despite controlled GVHD</a:t>
             </a:r>
             <a:endParaRPr lang="en-US" sz="1500" dirty="0"/>
           </a:p>

</xml_diff>